<commit_message>
Final cleanup: Fix PPT generation and remove all traces of Playwright
</commit_message>
<xml_diff>
--- a/Ahmed_Khalil_Validation_Demo.pptx
+++ b/Ahmed_Khalil_Validation_Demo.pptx
@@ -5,20 +5,20 @@
     <p:sldMasterId id="2147483648" r:id="rId1"/>
   </p:sldMasterIdLst>
   <p:sldIdLst>
-    <p:sldId id="256" r:id="rId2"/>
-    <p:sldId id="257" r:id="rId3"/>
-    <p:sldId id="258" r:id="rId4"/>
-    <p:sldId id="259" r:id="rId5"/>
-    <p:sldId id="260" r:id="rId6"/>
-    <p:sldId id="261" r:id="rId7"/>
-    <p:sldId id="262" r:id="rId8"/>
-    <p:sldId id="263" r:id="rId9"/>
-    <p:sldId id="264" r:id="rId10"/>
-    <p:sldId id="265" r:id="rId11"/>
-    <p:sldId id="266" r:id="rId12"/>
-    <p:sldId id="267" r:id="rId13"/>
-    <p:sldId id="268" r:id="rId14"/>
-    <p:sldId id="269" r:id="rId15"/>
+    <p:sldId id="256" r:id="rId7"/>
+    <p:sldId id="257" r:id="rId8"/>
+    <p:sldId id="258" r:id="rId9"/>
+    <p:sldId id="259" r:id="rId10"/>
+    <p:sldId id="260" r:id="rId11"/>
+    <p:sldId id="261" r:id="rId12"/>
+    <p:sldId id="262" r:id="rId13"/>
+    <p:sldId id="263" r:id="rId14"/>
+    <p:sldId id="264" r:id="rId15"/>
+    <p:sldId id="265" r:id="rId16"/>
+    <p:sldId id="266" r:id="rId17"/>
+    <p:sldId id="267" r:id="rId18"/>
+    <p:sldId id="268" r:id="rId19"/>
+    <p:sldId id="269" r:id="rId20"/>
   </p:sldIdLst>
   <p:sldSz cx="9144000" cy="6858000" type="screen4x3"/>
   <p:notesSz cx="6858000" cy="9144000"/>
@@ -117,22 +117,6 @@
       </a:defRPr>
     </a:lvl9pPr>
   </p:defaultTextStyle>
-  <p:extLst>
-    <p:ext uri="{EFAFB233-063F-42B5-8137-9DF3F51BA10A}">
-      <p15:sldGuideLst xmlns:p15="http://schemas.microsoft.com/office/powerpoint/2012/main">
-        <p15:guide id="1" orient="horz" pos="2160">
-          <p15:clr>
-            <a:srgbClr val="A4A3A4"/>
-          </p15:clr>
-        </p15:guide>
-        <p15:guide id="2" pos="2880">
-          <p15:clr>
-            <a:srgbClr val="A4A3A4"/>
-          </p15:clr>
-        </p15:guide>
-      </p15:sldGuideLst>
-    </p:ext>
-  </p:extLst>
 </p:presentation>
 </file>
 
@@ -174,9 +158,10 @@
           <a:lstStyle/>
           <a:p>
             <a:r>
-              <a:rPr lang="en-US"/>
+              <a:rPr lang="en-US" smtClean="0"/>
               <a:t>Click to edit Master title style</a:t>
             </a:r>
+            <a:endParaRPr lang="en-US"/>
           </a:p>
         </p:txBody>
       </p:sp>
@@ -292,9 +277,10 @@
           </a:lstStyle>
           <a:p>
             <a:r>
-              <a:rPr lang="en-US"/>
+              <a:rPr lang="en-US" smtClean="0"/>
               <a:t>Click to edit Master subtitle style</a:t>
             </a:r>
+            <a:endParaRPr lang="en-US"/>
           </a:p>
         </p:txBody>
       </p:sp>
@@ -315,7 +301,7 @@
           <a:p>
             <a:fld id="{5BCAD085-E8A6-8845-BD4E-CB4CCA059FC4}" type="datetimeFigureOut">
               <a:rPr lang="en-US" smtClean="0"/>
-              <a:t>4/25/26</a:t>
+              <a:t>1/27/13</a:t>
             </a:fld>
             <a:endParaRPr lang="en-US"/>
           </a:p>
@@ -409,9 +395,10 @@
           <a:lstStyle/>
           <a:p>
             <a:r>
-              <a:rPr lang="en-US"/>
+              <a:rPr lang="en-US" smtClean="0"/>
               <a:t>Click to edit Master title style</a:t>
             </a:r>
+            <a:endParaRPr lang="en-US"/>
           </a:p>
         </p:txBody>
       </p:sp>
@@ -432,37 +419,38 @@
           <a:p>
             <a:pPr lvl="0"/>
             <a:r>
-              <a:rPr lang="en-US"/>
+              <a:rPr lang="en-US" smtClean="0"/>
               <a:t>Click to edit Master text styles</a:t>
             </a:r>
           </a:p>
           <a:p>
             <a:pPr lvl="1"/>
             <a:r>
-              <a:rPr lang="en-US"/>
+              <a:rPr lang="en-US" smtClean="0"/>
               <a:t>Second level</a:t>
             </a:r>
           </a:p>
           <a:p>
             <a:pPr lvl="2"/>
             <a:r>
-              <a:rPr lang="en-US"/>
+              <a:rPr lang="en-US" smtClean="0"/>
               <a:t>Third level</a:t>
             </a:r>
           </a:p>
           <a:p>
             <a:pPr lvl="3"/>
             <a:r>
-              <a:rPr lang="en-US"/>
+              <a:rPr lang="en-US" smtClean="0"/>
               <a:t>Fourth level</a:t>
             </a:r>
           </a:p>
           <a:p>
             <a:pPr lvl="4"/>
             <a:r>
-              <a:rPr lang="en-US"/>
+              <a:rPr lang="en-US" smtClean="0"/>
               <a:t>Fifth level</a:t>
             </a:r>
+            <a:endParaRPr lang="en-US"/>
           </a:p>
         </p:txBody>
       </p:sp>
@@ -483,7 +471,7 @@
           <a:p>
             <a:fld id="{5BCAD085-E8A6-8845-BD4E-CB4CCA059FC4}" type="datetimeFigureOut">
               <a:rPr lang="en-US" smtClean="0"/>
-              <a:t>4/25/26</a:t>
+              <a:t>1/27/13</a:t>
             </a:fld>
             <a:endParaRPr lang="en-US"/>
           </a:p>
@@ -582,9 +570,10 @@
           <a:lstStyle/>
           <a:p>
             <a:r>
-              <a:rPr lang="en-US"/>
+              <a:rPr lang="en-US" smtClean="0"/>
               <a:t>Click to edit Master title style</a:t>
             </a:r>
+            <a:endParaRPr lang="en-US"/>
           </a:p>
         </p:txBody>
       </p:sp>
@@ -610,37 +599,38 @@
           <a:p>
             <a:pPr lvl="0"/>
             <a:r>
-              <a:rPr lang="en-US"/>
+              <a:rPr lang="en-US" smtClean="0"/>
               <a:t>Click to edit Master text styles</a:t>
             </a:r>
           </a:p>
           <a:p>
             <a:pPr lvl="1"/>
             <a:r>
-              <a:rPr lang="en-US"/>
+              <a:rPr lang="en-US" smtClean="0"/>
               <a:t>Second level</a:t>
             </a:r>
           </a:p>
           <a:p>
             <a:pPr lvl="2"/>
             <a:r>
-              <a:rPr lang="en-US"/>
+              <a:rPr lang="en-US" smtClean="0"/>
               <a:t>Third level</a:t>
             </a:r>
           </a:p>
           <a:p>
             <a:pPr lvl="3"/>
             <a:r>
-              <a:rPr lang="en-US"/>
+              <a:rPr lang="en-US" smtClean="0"/>
               <a:t>Fourth level</a:t>
             </a:r>
           </a:p>
           <a:p>
             <a:pPr lvl="4"/>
             <a:r>
-              <a:rPr lang="en-US"/>
+              <a:rPr lang="en-US" smtClean="0"/>
               <a:t>Fifth level</a:t>
             </a:r>
+            <a:endParaRPr lang="en-US"/>
           </a:p>
         </p:txBody>
       </p:sp>
@@ -661,7 +651,7 @@
           <a:p>
             <a:fld id="{5BCAD085-E8A6-8845-BD4E-CB4CCA059FC4}" type="datetimeFigureOut">
               <a:rPr lang="en-US" smtClean="0"/>
-              <a:t>4/25/26</a:t>
+              <a:t>1/27/13</a:t>
             </a:fld>
             <a:endParaRPr lang="en-US"/>
           </a:p>
@@ -755,9 +745,10 @@
           <a:lstStyle/>
           <a:p>
             <a:r>
-              <a:rPr lang="en-US"/>
+              <a:rPr lang="en-US" smtClean="0"/>
               <a:t>Click to edit Master title style</a:t>
             </a:r>
+            <a:endParaRPr lang="en-US"/>
           </a:p>
         </p:txBody>
       </p:sp>
@@ -778,37 +769,38 @@
           <a:p>
             <a:pPr lvl="0"/>
             <a:r>
-              <a:rPr lang="en-US"/>
+              <a:rPr lang="en-US" smtClean="0"/>
               <a:t>Click to edit Master text styles</a:t>
             </a:r>
           </a:p>
           <a:p>
             <a:pPr lvl="1"/>
             <a:r>
-              <a:rPr lang="en-US"/>
+              <a:rPr lang="en-US" smtClean="0"/>
               <a:t>Second level</a:t>
             </a:r>
           </a:p>
           <a:p>
             <a:pPr lvl="2"/>
             <a:r>
-              <a:rPr lang="en-US"/>
+              <a:rPr lang="en-US" smtClean="0"/>
               <a:t>Third level</a:t>
             </a:r>
           </a:p>
           <a:p>
             <a:pPr lvl="3"/>
             <a:r>
-              <a:rPr lang="en-US"/>
+              <a:rPr lang="en-US" smtClean="0"/>
               <a:t>Fourth level</a:t>
             </a:r>
           </a:p>
           <a:p>
             <a:pPr lvl="4"/>
             <a:r>
-              <a:rPr lang="en-US"/>
+              <a:rPr lang="en-US" smtClean="0"/>
               <a:t>Fifth level</a:t>
             </a:r>
+            <a:endParaRPr lang="en-US"/>
           </a:p>
         </p:txBody>
       </p:sp>
@@ -829,7 +821,7 @@
           <a:p>
             <a:fld id="{5BCAD085-E8A6-8845-BD4E-CB4CCA059FC4}" type="datetimeFigureOut">
               <a:rPr lang="en-US" smtClean="0"/>
-              <a:t>4/25/26</a:t>
+              <a:t>1/27/13</a:t>
             </a:fld>
             <a:endParaRPr lang="en-US"/>
           </a:p>
@@ -932,9 +924,10 @@
           </a:lstStyle>
           <a:p>
             <a:r>
-              <a:rPr lang="en-US"/>
+              <a:rPr lang="en-US" smtClean="0"/>
               <a:t>Click to edit Master title style</a:t>
             </a:r>
+            <a:endParaRPr lang="en-US"/>
           </a:p>
         </p:txBody>
       </p:sp>
@@ -1051,7 +1044,7 @@
           <a:p>
             <a:pPr lvl="0"/>
             <a:r>
-              <a:rPr lang="en-US"/>
+              <a:rPr lang="en-US" smtClean="0"/>
               <a:t>Click to edit Master text styles</a:t>
             </a:r>
           </a:p>
@@ -1074,7 +1067,7 @@
           <a:p>
             <a:fld id="{5BCAD085-E8A6-8845-BD4E-CB4CCA059FC4}" type="datetimeFigureOut">
               <a:rPr lang="en-US" smtClean="0"/>
-              <a:t>4/25/26</a:t>
+              <a:t>1/27/13</a:t>
             </a:fld>
             <a:endParaRPr lang="en-US"/>
           </a:p>
@@ -1168,9 +1161,10 @@
           <a:lstStyle/>
           <a:p>
             <a:r>
-              <a:rPr lang="en-US"/>
+              <a:rPr lang="en-US" smtClean="0"/>
               <a:t>Click to edit Master title style</a:t>
             </a:r>
+            <a:endParaRPr lang="en-US"/>
           </a:p>
         </p:txBody>
       </p:sp>
@@ -1224,37 +1218,38 @@
           <a:p>
             <a:pPr lvl="0"/>
             <a:r>
-              <a:rPr lang="en-US"/>
+              <a:rPr lang="en-US" smtClean="0"/>
               <a:t>Click to edit Master text styles</a:t>
             </a:r>
           </a:p>
           <a:p>
             <a:pPr lvl="1"/>
             <a:r>
-              <a:rPr lang="en-US"/>
+              <a:rPr lang="en-US" smtClean="0"/>
               <a:t>Second level</a:t>
             </a:r>
           </a:p>
           <a:p>
             <a:pPr lvl="2"/>
             <a:r>
-              <a:rPr lang="en-US"/>
+              <a:rPr lang="en-US" smtClean="0"/>
               <a:t>Third level</a:t>
             </a:r>
           </a:p>
           <a:p>
             <a:pPr lvl="3"/>
             <a:r>
-              <a:rPr lang="en-US"/>
+              <a:rPr lang="en-US" smtClean="0"/>
               <a:t>Fourth level</a:t>
             </a:r>
           </a:p>
           <a:p>
             <a:pPr lvl="4"/>
             <a:r>
-              <a:rPr lang="en-US"/>
+              <a:rPr lang="en-US" smtClean="0"/>
               <a:t>Fifth level</a:t>
             </a:r>
+            <a:endParaRPr lang="en-US"/>
           </a:p>
         </p:txBody>
       </p:sp>
@@ -1308,37 +1303,38 @@
           <a:p>
             <a:pPr lvl="0"/>
             <a:r>
-              <a:rPr lang="en-US"/>
+              <a:rPr lang="en-US" smtClean="0"/>
               <a:t>Click to edit Master text styles</a:t>
             </a:r>
           </a:p>
           <a:p>
             <a:pPr lvl="1"/>
             <a:r>
-              <a:rPr lang="en-US"/>
+              <a:rPr lang="en-US" smtClean="0"/>
               <a:t>Second level</a:t>
             </a:r>
           </a:p>
           <a:p>
             <a:pPr lvl="2"/>
             <a:r>
-              <a:rPr lang="en-US"/>
+              <a:rPr lang="en-US" smtClean="0"/>
               <a:t>Third level</a:t>
             </a:r>
           </a:p>
           <a:p>
             <a:pPr lvl="3"/>
             <a:r>
-              <a:rPr lang="en-US"/>
+              <a:rPr lang="en-US" smtClean="0"/>
               <a:t>Fourth level</a:t>
             </a:r>
           </a:p>
           <a:p>
             <a:pPr lvl="4"/>
             <a:r>
-              <a:rPr lang="en-US"/>
+              <a:rPr lang="en-US" smtClean="0"/>
               <a:t>Fifth level</a:t>
             </a:r>
+            <a:endParaRPr lang="en-US"/>
           </a:p>
         </p:txBody>
       </p:sp>
@@ -1359,7 +1355,7 @@
           <a:p>
             <a:fld id="{5BCAD085-E8A6-8845-BD4E-CB4CCA059FC4}" type="datetimeFigureOut">
               <a:rPr lang="en-US" smtClean="0"/>
-              <a:t>4/25/26</a:t>
+              <a:t>1/27/13</a:t>
             </a:fld>
             <a:endParaRPr lang="en-US"/>
           </a:p>
@@ -1457,9 +1453,10 @@
           </a:lstStyle>
           <a:p>
             <a:r>
-              <a:rPr lang="en-US"/>
+              <a:rPr lang="en-US" smtClean="0"/>
               <a:t>Click to edit Master title style</a:t>
             </a:r>
+            <a:endParaRPr lang="en-US"/>
           </a:p>
         </p:txBody>
       </p:sp>
@@ -1522,7 +1519,7 @@
           <a:p>
             <a:pPr lvl="0"/>
             <a:r>
-              <a:rPr lang="en-US"/>
+              <a:rPr lang="en-US" smtClean="0"/>
               <a:t>Click to edit Master text styles</a:t>
             </a:r>
           </a:p>
@@ -1578,37 +1575,38 @@
           <a:p>
             <a:pPr lvl="0"/>
             <a:r>
-              <a:rPr lang="en-US"/>
+              <a:rPr lang="en-US" smtClean="0"/>
               <a:t>Click to edit Master text styles</a:t>
             </a:r>
           </a:p>
           <a:p>
             <a:pPr lvl="1"/>
             <a:r>
-              <a:rPr lang="en-US"/>
+              <a:rPr lang="en-US" smtClean="0"/>
               <a:t>Second level</a:t>
             </a:r>
           </a:p>
           <a:p>
             <a:pPr lvl="2"/>
             <a:r>
-              <a:rPr lang="en-US"/>
+              <a:rPr lang="en-US" smtClean="0"/>
               <a:t>Third level</a:t>
             </a:r>
           </a:p>
           <a:p>
             <a:pPr lvl="3"/>
             <a:r>
-              <a:rPr lang="en-US"/>
+              <a:rPr lang="en-US" smtClean="0"/>
               <a:t>Fourth level</a:t>
             </a:r>
           </a:p>
           <a:p>
             <a:pPr lvl="4"/>
             <a:r>
-              <a:rPr lang="en-US"/>
+              <a:rPr lang="en-US" smtClean="0"/>
               <a:t>Fifth level</a:t>
             </a:r>
+            <a:endParaRPr lang="en-US"/>
           </a:p>
         </p:txBody>
       </p:sp>
@@ -1671,7 +1669,7 @@
           <a:p>
             <a:pPr lvl="0"/>
             <a:r>
-              <a:rPr lang="en-US"/>
+              <a:rPr lang="en-US" smtClean="0"/>
               <a:t>Click to edit Master text styles</a:t>
             </a:r>
           </a:p>
@@ -1727,37 +1725,38 @@
           <a:p>
             <a:pPr lvl="0"/>
             <a:r>
-              <a:rPr lang="en-US"/>
+              <a:rPr lang="en-US" smtClean="0"/>
               <a:t>Click to edit Master text styles</a:t>
             </a:r>
           </a:p>
           <a:p>
             <a:pPr lvl="1"/>
             <a:r>
-              <a:rPr lang="en-US"/>
+              <a:rPr lang="en-US" smtClean="0"/>
               <a:t>Second level</a:t>
             </a:r>
           </a:p>
           <a:p>
             <a:pPr lvl="2"/>
             <a:r>
-              <a:rPr lang="en-US"/>
+              <a:rPr lang="en-US" smtClean="0"/>
               <a:t>Third level</a:t>
             </a:r>
           </a:p>
           <a:p>
             <a:pPr lvl="3"/>
             <a:r>
-              <a:rPr lang="en-US"/>
+              <a:rPr lang="en-US" smtClean="0"/>
               <a:t>Fourth level</a:t>
             </a:r>
           </a:p>
           <a:p>
             <a:pPr lvl="4"/>
             <a:r>
-              <a:rPr lang="en-US"/>
+              <a:rPr lang="en-US" smtClean="0"/>
               <a:t>Fifth level</a:t>
             </a:r>
+            <a:endParaRPr lang="en-US"/>
           </a:p>
         </p:txBody>
       </p:sp>
@@ -1778,7 +1777,7 @@
           <a:p>
             <a:fld id="{5BCAD085-E8A6-8845-BD4E-CB4CCA059FC4}" type="datetimeFigureOut">
               <a:rPr lang="en-US" smtClean="0"/>
-              <a:t>4/25/26</a:t>
+              <a:t>1/27/13</a:t>
             </a:fld>
             <a:endParaRPr lang="en-US"/>
           </a:p>
@@ -1872,9 +1871,10 @@
           <a:lstStyle/>
           <a:p>
             <a:r>
-              <a:rPr lang="en-US"/>
+              <a:rPr lang="en-US" smtClean="0"/>
               <a:t>Click to edit Master title style</a:t>
             </a:r>
+            <a:endParaRPr lang="en-US"/>
           </a:p>
         </p:txBody>
       </p:sp>
@@ -1895,7 +1895,7 @@
           <a:p>
             <a:fld id="{5BCAD085-E8A6-8845-BD4E-CB4CCA059FC4}" type="datetimeFigureOut">
               <a:rPr lang="en-US" smtClean="0"/>
-              <a:t>4/25/26</a:t>
+              <a:t>1/27/13</a:t>
             </a:fld>
             <a:endParaRPr lang="en-US"/>
           </a:p>
@@ -1990,7 +1990,7 @@
           <a:p>
             <a:fld id="{5BCAD085-E8A6-8845-BD4E-CB4CCA059FC4}" type="datetimeFigureOut">
               <a:rPr lang="en-US" smtClean="0"/>
-              <a:t>4/25/26</a:t>
+              <a:t>1/27/13</a:t>
             </a:fld>
             <a:endParaRPr lang="en-US"/>
           </a:p>
@@ -2093,9 +2093,10 @@
           </a:lstStyle>
           <a:p>
             <a:r>
-              <a:rPr lang="en-US"/>
+              <a:rPr lang="en-US" smtClean="0"/>
               <a:t>Click to edit Master title style</a:t>
             </a:r>
+            <a:endParaRPr lang="en-US"/>
           </a:p>
         </p:txBody>
       </p:sp>
@@ -2149,37 +2150,38 @@
           <a:p>
             <a:pPr lvl="0"/>
             <a:r>
-              <a:rPr lang="en-US"/>
+              <a:rPr lang="en-US" smtClean="0"/>
               <a:t>Click to edit Master text styles</a:t>
             </a:r>
           </a:p>
           <a:p>
             <a:pPr lvl="1"/>
             <a:r>
-              <a:rPr lang="en-US"/>
+              <a:rPr lang="en-US" smtClean="0"/>
               <a:t>Second level</a:t>
             </a:r>
           </a:p>
           <a:p>
             <a:pPr lvl="2"/>
             <a:r>
-              <a:rPr lang="en-US"/>
+              <a:rPr lang="en-US" smtClean="0"/>
               <a:t>Third level</a:t>
             </a:r>
           </a:p>
           <a:p>
             <a:pPr lvl="3"/>
             <a:r>
-              <a:rPr lang="en-US"/>
+              <a:rPr lang="en-US" smtClean="0"/>
               <a:t>Fourth level</a:t>
             </a:r>
           </a:p>
           <a:p>
             <a:pPr lvl="4"/>
             <a:r>
-              <a:rPr lang="en-US"/>
+              <a:rPr lang="en-US" smtClean="0"/>
               <a:t>Fifth level</a:t>
             </a:r>
+            <a:endParaRPr lang="en-US"/>
           </a:p>
         </p:txBody>
       </p:sp>
@@ -2242,7 +2244,7 @@
           <a:p>
             <a:pPr lvl="0"/>
             <a:r>
-              <a:rPr lang="en-US"/>
+              <a:rPr lang="en-US" smtClean="0"/>
               <a:t>Click to edit Master text styles</a:t>
             </a:r>
           </a:p>
@@ -2265,7 +2267,7 @@
           <a:p>
             <a:fld id="{5BCAD085-E8A6-8845-BD4E-CB4CCA059FC4}" type="datetimeFigureOut">
               <a:rPr lang="en-US" smtClean="0"/>
-              <a:t>4/25/26</a:t>
+              <a:t>1/27/13</a:t>
             </a:fld>
             <a:endParaRPr lang="en-US"/>
           </a:p>
@@ -2368,9 +2370,10 @@
           </a:lstStyle>
           <a:p>
             <a:r>
-              <a:rPr lang="en-US"/>
+              <a:rPr lang="en-US" smtClean="0"/>
               <a:t>Click to edit Master title style</a:t>
             </a:r>
+            <a:endParaRPr lang="en-US"/>
           </a:p>
         </p:txBody>
       </p:sp>
@@ -2494,7 +2497,7 @@
           <a:p>
             <a:pPr lvl="0"/>
             <a:r>
-              <a:rPr lang="en-US"/>
+              <a:rPr lang="en-US" smtClean="0"/>
               <a:t>Click to edit Master text styles</a:t>
             </a:r>
           </a:p>
@@ -2517,7 +2520,7 @@
           <a:p>
             <a:fld id="{5BCAD085-E8A6-8845-BD4E-CB4CCA059FC4}" type="datetimeFigureOut">
               <a:rPr lang="en-US" smtClean="0"/>
-              <a:t>4/25/26</a:t>
+              <a:t>1/27/13</a:t>
             </a:fld>
             <a:endParaRPr lang="en-US"/>
           </a:p>
@@ -2626,9 +2629,10 @@
           <a:lstStyle/>
           <a:p>
             <a:r>
-              <a:rPr lang="en-US"/>
+              <a:rPr lang="en-US" smtClean="0"/>
               <a:t>Click to edit Master title style</a:t>
             </a:r>
+            <a:endParaRPr lang="en-US"/>
           </a:p>
         </p:txBody>
       </p:sp>
@@ -2659,37 +2663,38 @@
           <a:p>
             <a:pPr lvl="0"/>
             <a:r>
-              <a:rPr lang="en-US"/>
+              <a:rPr lang="en-US" smtClean="0"/>
               <a:t>Click to edit Master text styles</a:t>
             </a:r>
           </a:p>
           <a:p>
             <a:pPr lvl="1"/>
             <a:r>
-              <a:rPr lang="en-US"/>
+              <a:rPr lang="en-US" smtClean="0"/>
               <a:t>Second level</a:t>
             </a:r>
           </a:p>
           <a:p>
             <a:pPr lvl="2"/>
             <a:r>
-              <a:rPr lang="en-US"/>
+              <a:rPr lang="en-US" smtClean="0"/>
               <a:t>Third level</a:t>
             </a:r>
           </a:p>
           <a:p>
             <a:pPr lvl="3"/>
             <a:r>
-              <a:rPr lang="en-US"/>
+              <a:rPr lang="en-US" smtClean="0"/>
               <a:t>Fourth level</a:t>
             </a:r>
           </a:p>
           <a:p>
             <a:pPr lvl="4"/>
             <a:r>
-              <a:rPr lang="en-US"/>
+              <a:rPr lang="en-US" smtClean="0"/>
               <a:t>Fifth level</a:t>
             </a:r>
+            <a:endParaRPr lang="en-US"/>
           </a:p>
         </p:txBody>
       </p:sp>
@@ -2728,7 +2733,7 @@
           <a:p>
             <a:fld id="{5BCAD085-E8A6-8845-BD4E-CB4CCA059FC4}" type="datetimeFigureOut">
               <a:rPr lang="en-US" smtClean="0"/>
-              <a:t>4/25/26</a:t>
+              <a:t>1/27/13</a:t>
             </a:fld>
             <a:endParaRPr lang="en-US"/>
           </a:p>
@@ -3087,7 +3092,7 @@
 </file>
 
 <file path=ppt/slides/slide1.xml><?xml version="1.0" encoding="utf-8"?>
-<p:sld xmlns:a="http://schemas.openxmlformats.org/drawingml/2006/main" xmlns:r="http://schemas.openxmlformats.org/officeDocument/2006/relationships" xmlns:p="http://schemas.openxmlformats.org/presentationml/2006/main">
+<p:sld xmlns:a="http://schemas.openxmlformats.org/drawingml/2006/main" xmlns:p="http://schemas.openxmlformats.org/presentationml/2006/main" xmlns:r="http://schemas.openxmlformats.org/officeDocument/2006/relationships">
   <p:cSld>
     <p:bg>
       <p:bgPr>
@@ -3103,14 +3108,7 @@
         <p:cNvGrpSpPr/>
         <p:nvPr/>
       </p:nvGrpSpPr>
-      <p:grpSpPr>
-        <a:xfrm>
-          <a:off x="0" y="0"/>
-          <a:ext cx="0" cy="0"/>
-          <a:chOff x="0" y="0"/>
-          <a:chExt cx="0" cy="0"/>
-        </a:xfrm>
-      </p:grpSpPr>
+      <p:grpSpPr/>
       <p:sp>
         <p:nvSpPr>
           <p:cNvPr id="2" name="Title 1"/>
@@ -3127,9 +3125,9 @@
           <a:lstStyle/>
           <a:p>
             <a:pPr>
-              <a:defRPr sz="4400" b="1">
-                <a:solidFill>
-                  <a:srgbClr val="0F172A"/>
+              <a:defRPr b="1" sz="4000">
+                <a:solidFill>
+                  <a:srgbClr val="003366"/>
                 </a:solidFill>
               </a:defRPr>
             </a:pPr>
@@ -3155,9 +3153,9 @@
           <a:lstStyle/>
           <a:p>
             <a:pPr>
-              <a:defRPr sz="2400">
-                <a:solidFill>
-                  <a:srgbClr val="0284C7"/>
+              <a:defRPr sz="2800">
+                <a:solidFill>
+                  <a:srgbClr val="000000"/>
                 </a:solidFill>
               </a:defRPr>
             </a:pPr>
@@ -3170,6 +3168,7 @@
               <a:t>Student ID: U23LYAZ801</a:t>
             </a:r>
           </a:p>
+          <a:p/>
           <a:p>
             <a:r>
               <a:t>Subject: Building and Testing a Localized AWS Ecosystem</a:t>
@@ -3186,7 +3185,7 @@
 </file>
 
 <file path=ppt/slides/slide10.xml><?xml version="1.0" encoding="utf-8"?>
-<p:sld xmlns:a="http://schemas.openxmlformats.org/drawingml/2006/main" xmlns:r="http://schemas.openxmlformats.org/officeDocument/2006/relationships" xmlns:p="http://schemas.openxmlformats.org/presentationml/2006/main">
+<p:sld xmlns:a="http://schemas.openxmlformats.org/drawingml/2006/main" xmlns:p="http://schemas.openxmlformats.org/presentationml/2006/main" xmlns:r="http://schemas.openxmlformats.org/officeDocument/2006/relationships">
   <p:cSld>
     <p:bg>
       <p:bgPr>
@@ -3202,14 +3201,7 @@
         <p:cNvGrpSpPr/>
         <p:nvPr/>
       </p:nvGrpSpPr>
-      <p:grpSpPr>
-        <a:xfrm>
-          <a:off x="0" y="0"/>
-          <a:ext cx="0" cy="0"/>
-          <a:chOff x="0" y="0"/>
-          <a:chExt cx="0" cy="0"/>
-        </a:xfrm>
-      </p:grpSpPr>
+      <p:grpSpPr/>
       <p:sp>
         <p:nvSpPr>
           <p:cNvPr id="2" name="Title 1"/>
@@ -3228,7 +3220,7 @@
             <a:pPr>
               <a:defRPr b="1">
                 <a:solidFill>
-                  <a:srgbClr val="0284C7"/>
+                  <a:srgbClr val="003366"/>
                 </a:solidFill>
               </a:defRPr>
             </a:pPr>
@@ -3254,49 +3246,47 @@
           <a:lstStyle/>
           <a:p>
             <a:pPr>
-              <a:defRPr sz="2000">
-                <a:solidFill>
-                  <a:srgbClr val="334155"/>
+              <a:spcAft>
+                <a:spcPts val="1200"/>
+              </a:spcAft>
+              <a:defRPr sz="2200">
+                <a:solidFill>
+                  <a:srgbClr val="000000"/>
                 </a:solidFill>
               </a:defRPr>
             </a:pPr>
             <a:r>
-              <a:rPr dirty="0"/>
-              <a:t>• State Management: The app is a 'State Machine.' It tracks 'Idle,' 'Uploading,' or 'Success' to change the UI (like progress spinners) in real-time.</a:t>
+              <a:t>• State Management: The app is a 'State Machine.' It tracks whether it is currently 'Idle,' 'Uploading,' or if it has reached a 'Success' state.</a:t>
             </a:r>
           </a:p>
           <a:p>
             <a:pPr>
-              <a:defRPr sz="2000">
-                <a:solidFill>
-                  <a:srgbClr val="334155"/>
+              <a:spcAft>
+                <a:spcPts val="1200"/>
+              </a:spcAft>
+              <a:defRPr sz="2200">
+                <a:solidFill>
+                  <a:srgbClr val="000000"/>
                 </a:solidFill>
               </a:defRPr>
             </a:pPr>
             <a:r>
-              <a:rPr dirty="0"/>
-              <a:t>• Visual Excellence: </a:t>
-            </a:r>
-            <a:r>
-              <a:rPr lang="en-US" dirty="0"/>
-              <a:t>U</a:t>
-            </a:r>
-            <a:r>
-              <a:rPr dirty="0"/>
-              <a:t>sed Vanilla CSS for a premium dark-mode design. </a:t>
+              <a:t>• This allows the UI to change (e.g., showing a progress spinner) in real-time.</a:t>
             </a:r>
           </a:p>
           <a:p>
             <a:pPr>
-              <a:defRPr sz="2000">
-                <a:solidFill>
-                  <a:srgbClr val="334155"/>
+              <a:spcAft>
+                <a:spcPts val="1200"/>
+              </a:spcAft>
+              <a:defRPr sz="2200">
+                <a:solidFill>
+                  <a:srgbClr val="000000"/>
                 </a:solidFill>
               </a:defRPr>
             </a:pPr>
             <a:r>
-              <a:rPr dirty="0"/>
-              <a:t>• Readable Code: Used 'Clean Class Names' </a:t>
+              <a:t>• Visual Excellence: We used Vanilla CSS to create a premium, dark-mode design. Used 'Clean Class Names' (like .upload-btn).</a:t>
             </a:r>
           </a:p>
         </p:txBody>
@@ -3310,7 +3300,7 @@
 </file>
 
 <file path=ppt/slides/slide11.xml><?xml version="1.0" encoding="utf-8"?>
-<p:sld xmlns:a="http://schemas.openxmlformats.org/drawingml/2006/main" xmlns:r="http://schemas.openxmlformats.org/officeDocument/2006/relationships" xmlns:p="http://schemas.openxmlformats.org/presentationml/2006/main">
+<p:sld xmlns:a="http://schemas.openxmlformats.org/drawingml/2006/main" xmlns:p="http://schemas.openxmlformats.org/presentationml/2006/main" xmlns:r="http://schemas.openxmlformats.org/officeDocument/2006/relationships">
   <p:cSld>
     <p:bg>
       <p:bgPr>
@@ -3326,14 +3316,7 @@
         <p:cNvGrpSpPr/>
         <p:nvPr/>
       </p:nvGrpSpPr>
-      <p:grpSpPr>
-        <a:xfrm>
-          <a:off x="0" y="0"/>
-          <a:ext cx="0" cy="0"/>
-          <a:chOff x="0" y="0"/>
-          <a:chExt cx="0" cy="0"/>
-        </a:xfrm>
-      </p:grpSpPr>
+      <p:grpSpPr/>
       <p:sp>
         <p:nvSpPr>
           <p:cNvPr id="2" name="Title 1"/>
@@ -3352,12 +3335,12 @@
             <a:pPr>
               <a:defRPr b="1">
                 <a:solidFill>
-                  <a:srgbClr val="0284C7"/>
+                  <a:srgbClr val="003366"/>
                 </a:solidFill>
               </a:defRPr>
             </a:pPr>
             <a:r>
-              <a:t>6. The Audit (Playwright Validation)</a:t>
+              <a:t>6. Manual Validation: The Audit</a:t>
             </a:r>
           </a:p>
         </p:txBody>
@@ -3378,49 +3361,62 @@
           <a:lstStyle/>
           <a:p>
             <a:pPr>
-              <a:defRPr sz="2000">
-                <a:solidFill>
-                  <a:srgbClr val="334155"/>
+              <a:spcAft>
+                <a:spcPts val="1200"/>
+              </a:spcAft>
+              <a:defRPr sz="2200">
+                <a:solidFill>
+                  <a:srgbClr val="000000"/>
                 </a:solidFill>
               </a:defRPr>
             </a:pPr>
             <a:r>
-              <a:rPr dirty="0"/>
-              <a:t>As a Lead QA Engineer, we don't just hope it works; we prove it.</a:t>
+              <a:t>In this demo, we don't just hope it works; we prove it manually.</a:t>
             </a:r>
           </a:p>
           <a:p>
             <a:pPr>
-              <a:defRPr sz="2000">
-                <a:solidFill>
-                  <a:srgbClr val="334155"/>
+              <a:spcAft>
+                <a:spcPts val="1200"/>
+              </a:spcAft>
+              <a:defRPr sz="2200">
+                <a:solidFill>
+                  <a:srgbClr val="000000"/>
                 </a:solidFill>
               </a:defRPr>
             </a:pPr>
             <a:r>
-              <a:rPr dirty="0"/>
-              <a:t>1. Automated Interaction: The Playwright Robot opens the browser, finds the upload button, and injects a test file.</a:t>
+              <a:t>1. Direct Action: Upload a real document through the React Dashboard.</a:t>
             </a:r>
           </a:p>
           <a:p>
             <a:pPr>
-              <a:defRPr sz="2000">
-                <a:solidFill>
-                  <a:srgbClr val="334155"/>
+              <a:spcAft>
+                <a:spcPts val="1200"/>
+              </a:spcAft>
+              <a:defRPr sz="2200">
+                <a:solidFill>
+                  <a:srgbClr val="000000"/>
                 </a:solidFill>
               </a:defRPr>
             </a:pPr>
             <a:r>
-              <a:rPr dirty="0"/>
-              <a:t>2. API Interrogation: The Robot talks directly to the </a:t>
-            </a:r>
-            <a:r>
-              <a:rPr dirty="0" err="1"/>
-              <a:t>LocalStack</a:t>
-            </a:r>
-            <a:r>
-              <a:rPr dirty="0"/>
-              <a:t> API to verify the file actually exists in the bucket.</a:t>
+              <a:t>2. Backend Interrogation: Use the custom 'view_logs.js' tool to see the Cloud's brain.</a:t>
+            </a:r>
+          </a:p>
+          <a:p>
+            <a:pPr>
+              <a:spcAft>
+                <a:spcPts val="1200"/>
+              </a:spcAft>
+              <a:defRPr sz="2200">
+                <a:solidFill>
+                  <a:srgbClr val="000000"/>
+                </a:solidFill>
+              </a:defRPr>
+            </a:pPr>
+            <a:r>
+              <a:t>3. Proof: The logs explicitly show the S3 event triggering the Lambda worker.</a:t>
             </a:r>
           </a:p>
         </p:txBody>
@@ -3434,7 +3430,7 @@
 </file>
 
 <file path=ppt/slides/slide12.xml><?xml version="1.0" encoding="utf-8"?>
-<p:sld xmlns:a="http://schemas.openxmlformats.org/drawingml/2006/main" xmlns:r="http://schemas.openxmlformats.org/officeDocument/2006/relationships" xmlns:p="http://schemas.openxmlformats.org/presentationml/2006/main">
+<p:sld xmlns:a="http://schemas.openxmlformats.org/drawingml/2006/main" xmlns:p="http://schemas.openxmlformats.org/presentationml/2006/main" xmlns:r="http://schemas.openxmlformats.org/officeDocument/2006/relationships">
   <p:cSld>
     <p:bg>
       <p:bgPr>
@@ -3450,14 +3446,7 @@
         <p:cNvGrpSpPr/>
         <p:nvPr/>
       </p:nvGrpSpPr>
-      <p:grpSpPr>
-        <a:xfrm>
-          <a:off x="0" y="0"/>
-          <a:ext cx="0" cy="0"/>
-          <a:chOff x="0" y="0"/>
-          <a:chExt cx="0" cy="0"/>
-        </a:xfrm>
-      </p:grpSpPr>
+      <p:grpSpPr/>
       <p:sp>
         <p:nvSpPr>
           <p:cNvPr id="2" name="Title 1"/>
@@ -3476,12 +3465,12 @@
             <a:pPr>
               <a:defRPr b="1">
                 <a:solidFill>
-                  <a:srgbClr val="0284C7"/>
+                  <a:srgbClr val="003366"/>
                 </a:solidFill>
               </a:defRPr>
             </a:pPr>
             <a:r>
-              <a:t>6. The Audit (Continued)</a:t>
+              <a:t>6. Manual Validation (Continued)</a:t>
             </a:r>
           </a:p>
         </p:txBody>
@@ -3502,26 +3491,47 @@
           <a:lstStyle/>
           <a:p>
             <a:pPr>
-              <a:defRPr sz="2000">
-                <a:solidFill>
-                  <a:srgbClr val="334155"/>
+              <a:spcAft>
+                <a:spcPts val="1200"/>
+              </a:spcAft>
+              <a:defRPr sz="2200">
+                <a:solidFill>
+                  <a:srgbClr val="000000"/>
                 </a:solidFill>
               </a:defRPr>
             </a:pPr>
             <a:r>
-              <a:t>3. Log Verification: The Robot checks the CloudWatch Logbook to ensure the Lambda worker actually recorded a 'Validation Event.'</a:t>
+              <a:t>• The Audit Trail: Every upload generates a unique Request ID in CloudWatch.</a:t>
             </a:r>
           </a:p>
           <a:p>
             <a:pPr>
-              <a:defRPr sz="2000">
-                <a:solidFill>
-                  <a:srgbClr val="334155"/>
+              <a:spcAft>
+                <a:spcPts val="1200"/>
+              </a:spcAft>
+              <a:defRPr sz="2200">
+                <a:solidFill>
+                  <a:srgbClr val="000000"/>
                 </a:solidFill>
               </a:defRPr>
             </a:pPr>
             <a:r>
-              <a:t>• This ensures the entire backend pipeline is functioning correctly, not just the frontend UI.</a:t>
+              <a:t>• Transparency: We can see the exact size, timestamp, and success status of the validation.</a:t>
+            </a:r>
+          </a:p>
+          <a:p>
+            <a:pPr>
+              <a:spcAft>
+                <a:spcPts val="1200"/>
+              </a:spcAft>
+              <a:defRPr sz="2200">
+                <a:solidFill>
+                  <a:srgbClr val="000000"/>
+                </a:solidFill>
+              </a:defRPr>
+            </a:pPr>
+            <a:r>
+              <a:t>• Stability: Removing automated robots ensures the live demo is 100% controlled by the presenter.</a:t>
             </a:r>
           </a:p>
         </p:txBody>
@@ -3535,7 +3545,7 @@
 </file>
 
 <file path=ppt/slides/slide13.xml><?xml version="1.0" encoding="utf-8"?>
-<p:sld xmlns:a="http://schemas.openxmlformats.org/drawingml/2006/main" xmlns:r="http://schemas.openxmlformats.org/officeDocument/2006/relationships" xmlns:p="http://schemas.openxmlformats.org/presentationml/2006/main">
+<p:sld xmlns:a="http://schemas.openxmlformats.org/drawingml/2006/main" xmlns:p="http://schemas.openxmlformats.org/presentationml/2006/main" xmlns:r="http://schemas.openxmlformats.org/officeDocument/2006/relationships">
   <p:cSld>
     <p:bg>
       <p:bgPr>
@@ -3551,14 +3561,7 @@
         <p:cNvGrpSpPr/>
         <p:nvPr/>
       </p:nvGrpSpPr>
-      <p:grpSpPr>
-        <a:xfrm>
-          <a:off x="0" y="0"/>
-          <a:ext cx="0" cy="0"/>
-          <a:chOff x="0" y="0"/>
-          <a:chExt cx="0" cy="0"/>
-        </a:xfrm>
-      </p:grpSpPr>
+      <p:grpSpPr/>
       <p:sp>
         <p:nvSpPr>
           <p:cNvPr id="2" name="Title 1"/>
@@ -3577,7 +3580,7 @@
             <a:pPr>
               <a:defRPr>
                 <a:solidFill>
-                  <a:srgbClr val="0284C7"/>
+                  <a:srgbClr val="003366"/>
                 </a:solidFill>
               </a:defRPr>
             </a:pPr>
@@ -3596,8 +3599,8 @@
           <p:nvPr/>
         </p:nvGraphicFramePr>
         <p:xfrm>
-          <a:off x="457200" y="1371600"/>
-          <a:ext cx="8229600" cy="5029200"/>
+          <a:off x="457200" y="1097280"/>
+          <a:ext cx="8229600" cy="5486400"/>
         </p:xfrm>
         <a:graphic>
           <a:graphicData uri="http://schemas.openxmlformats.org/drawingml/2006/table">
@@ -3606,31 +3609,19 @@
                 <a:tableStyleId>{5C22544A-7EE6-4342-B048-85BDC9FD1C3A}</a:tableStyleId>
               </a:tblPr>
               <a:tblGrid>
-                <a:gridCol w="2011680">
-                  <a:extLst>
-                    <a:ext uri="{9D8B030D-6E8A-4147-A177-3AD203B41FA5}">
-                      <a16:colId xmlns:a16="http://schemas.microsoft.com/office/drawing/2014/main" val="20000"/>
-                    </a:ext>
-                  </a:extLst>
-                </a:gridCol>
-                <a:gridCol w="6217920">
-                  <a:extLst>
-                    <a:ext uri="{9D8B030D-6E8A-4147-A177-3AD203B41FA5}">
-                      <a16:colId xmlns:a16="http://schemas.microsoft.com/office/drawing/2014/main" val="20001"/>
-                    </a:ext>
-                  </a:extLst>
-                </a:gridCol>
+                <a:gridCol w="2011680"/>
+                <a:gridCol w="6217920"/>
               </a:tblGrid>
-              <a:tr h="457200">
+              <a:tr h="685800">
                 <a:tc>
                   <a:txBody>
                     <a:bodyPr/>
                     <a:lstStyle/>
                     <a:p>
                       <a:pPr>
-                        <a:defRPr sz="1100" b="1">
+                        <a:defRPr sz="1200" b="1">
                           <a:solidFill>
-                            <a:srgbClr val="334155"/>
+                            <a:srgbClr val="000000"/>
                           </a:solidFill>
                         </a:defRPr>
                       </a:pPr>
@@ -3641,7 +3632,7 @@
                   </a:txBody>
                   <a:tcPr>
                     <a:solidFill>
-                      <a:srgbClr val="E2E8F0"/>
+                      <a:srgbClr val="F0F0F0"/>
                     </a:solidFill>
                   </a:tcPr>
                 </a:tc>
@@ -3651,9 +3642,9 @@
                     <a:lstStyle/>
                     <a:p>
                       <a:pPr>
-                        <a:defRPr sz="1100" b="1">
+                        <a:defRPr sz="1200" b="1">
                           <a:solidFill>
-                            <a:srgbClr val="334155"/>
+                            <a:srgbClr val="000000"/>
                           </a:solidFill>
                         </a:defRPr>
                       </a:pPr>
@@ -3664,26 +3655,21 @@
                   </a:txBody>
                   <a:tcPr>
                     <a:solidFill>
-                      <a:srgbClr val="E2E8F0"/>
+                      <a:srgbClr val="F0F0F0"/>
                     </a:solidFill>
                   </a:tcPr>
                 </a:tc>
-                <a:extLst>
-                  <a:ext uri="{0D108BD9-81ED-4DB2-BD59-A6C34878D82A}">
-                    <a16:rowId xmlns:a16="http://schemas.microsoft.com/office/drawing/2014/main" val="10000"/>
-                  </a:ext>
-                </a:extLst>
               </a:tr>
-              <a:tr h="457200">
+              <a:tr h="685800">
                 <a:tc>
                   <a:txBody>
                     <a:bodyPr/>
                     <a:lstStyle/>
                     <a:p>
                       <a:pPr>
-                        <a:defRPr sz="1100">
+                        <a:defRPr sz="1200">
                           <a:solidFill>
-                            <a:srgbClr val="334155"/>
+                            <a:srgbClr val="000000"/>
                           </a:solidFill>
                         </a:defRPr>
                       </a:pPr>
@@ -3700,80 +3686,30 @@
                     <a:lstStyle/>
                     <a:p>
                       <a:pPr>
-                        <a:defRPr sz="1100">
+                        <a:defRPr sz="1200">
                           <a:solidFill>
-                            <a:srgbClr val="334155"/>
+                            <a:srgbClr val="000000"/>
                           </a:solidFill>
                         </a:defRPr>
                       </a:pPr>
                       <a:r>
-                        <a:t>Instructions to build/start the Magic Box (LocalStack).</a:t>
+                        <a:t>Instructions to build and start the 'Magic Box' (LocalStack).</a:t>
                       </a:r>
                     </a:p>
                   </a:txBody>
                   <a:tcPr/>
                 </a:tc>
-                <a:extLst>
-                  <a:ext uri="{0D108BD9-81ED-4DB2-BD59-A6C34878D82A}">
-                    <a16:rowId xmlns:a16="http://schemas.microsoft.com/office/drawing/2014/main" val="10001"/>
-                  </a:ext>
-                </a:extLst>
               </a:tr>
-              <a:tr h="457200">
+              <a:tr h="685800">
                 <a:tc>
                   <a:txBody>
                     <a:bodyPr/>
                     <a:lstStyle/>
                     <a:p>
                       <a:pPr>
-                        <a:defRPr sz="1100">
+                        <a:defRPr sz="1200">
                           <a:solidFill>
-                            <a:srgbClr val="334155"/>
-                          </a:solidFill>
-                        </a:defRPr>
-                      </a:pPr>
-                      <a:r>
-                        <a:t>package.json (Root)</a:t>
-                      </a:r>
-                    </a:p>
-                  </a:txBody>
-                  <a:tcPr/>
-                </a:tc>
-                <a:tc>
-                  <a:txBody>
-                    <a:bodyPr/>
-                    <a:lstStyle/>
-                    <a:p>
-                      <a:pPr>
-                        <a:defRPr sz="1100">
-                          <a:solidFill>
-                            <a:srgbClr val="334155"/>
-                          </a:solidFill>
-                        </a:defRPr>
-                      </a:pPr>
-                      <a:r>
-                        <a:t>The remote control to start the demo with one command.</a:t>
-                      </a:r>
-                    </a:p>
-                  </a:txBody>
-                  <a:tcPr/>
-                </a:tc>
-                <a:extLst>
-                  <a:ext uri="{0D108BD9-81ED-4DB2-BD59-A6C34878D82A}">
-                    <a16:rowId xmlns:a16="http://schemas.microsoft.com/office/drawing/2014/main" val="10002"/>
-                  </a:ext>
-                </a:extLst>
-              </a:tr>
-              <a:tr h="457200">
-                <a:tc>
-                  <a:txBody>
-                    <a:bodyPr/>
-                    <a:lstStyle/>
-                    <a:p>
-                      <a:pPr>
-                        <a:defRPr sz="1100">
-                          <a:solidFill>
-                            <a:srgbClr val="334155"/>
+                            <a:srgbClr val="000000"/>
                           </a:solidFill>
                         </a:defRPr>
                       </a:pPr>
@@ -3790,35 +3726,30 @@
                     <a:lstStyle/>
                     <a:p>
                       <a:pPr>
-                        <a:defRPr sz="1100">
+                        <a:defRPr sz="1200">
                           <a:solidFill>
-                            <a:srgbClr val="334155"/>
+                            <a:srgbClr val="000000"/>
                           </a:solidFill>
                         </a:defRPr>
                       </a:pPr>
                       <a:r>
-                        <a:t>The blueprint for S3 buckets and Lambda workers.</a:t>
+                        <a:t>Blueprint for S3 buckets and Lambda workers.</a:t>
                       </a:r>
                     </a:p>
                   </a:txBody>
                   <a:tcPr/>
                 </a:tc>
-                <a:extLst>
-                  <a:ext uri="{0D108BD9-81ED-4DB2-BD59-A6C34878D82A}">
-                    <a16:rowId xmlns:a16="http://schemas.microsoft.com/office/drawing/2014/main" val="10003"/>
-                  </a:ext>
-                </a:extLst>
               </a:tr>
-              <a:tr h="457200">
+              <a:tr h="685800">
                 <a:tc>
                   <a:txBody>
                     <a:bodyPr/>
                     <a:lstStyle/>
                     <a:p>
                       <a:pPr>
-                        <a:defRPr sz="1100">
+                        <a:defRPr sz="1200">
                           <a:solidFill>
-                            <a:srgbClr val="334155"/>
+                            <a:srgbClr val="000000"/>
                           </a:solidFill>
                         </a:defRPr>
                       </a:pPr>
@@ -3835,9 +3766,9 @@
                     <a:lstStyle/>
                     <a:p>
                       <a:pPr>
-                        <a:defRPr sz="1100">
+                        <a:defRPr sz="1200">
                           <a:solidFill>
-                            <a:srgbClr val="334155"/>
+                            <a:srgbClr val="000000"/>
                           </a:solidFill>
                         </a:defRPr>
                       </a:pPr>
@@ -3848,22 +3779,17 @@
                   </a:txBody>
                   <a:tcPr/>
                 </a:tc>
-                <a:extLst>
-                  <a:ext uri="{0D108BD9-81ED-4DB2-BD59-A6C34878D82A}">
-                    <a16:rowId xmlns:a16="http://schemas.microsoft.com/office/drawing/2014/main" val="10004"/>
-                  </a:ext>
-                </a:extLst>
               </a:tr>
-              <a:tr h="457200">
+              <a:tr h="685800">
                 <a:tc>
                   <a:txBody>
                     <a:bodyPr/>
                     <a:lstStyle/>
                     <a:p>
                       <a:pPr>
-                        <a:defRPr sz="1100">
+                        <a:defRPr sz="1200">
                           <a:solidFill>
-                            <a:srgbClr val="334155"/>
+                            <a:srgbClr val="000000"/>
                           </a:solidFill>
                         </a:defRPr>
                       </a:pPr>
@@ -3880,9 +3806,9 @@
                     <a:lstStyle/>
                     <a:p>
                       <a:pPr>
-                        <a:defRPr sz="1100">
+                        <a:defRPr sz="1200">
                           <a:solidFill>
-                            <a:srgbClr val="334155"/>
+                            <a:srgbClr val="000000"/>
                           </a:solidFill>
                         </a:defRPr>
                       </a:pPr>
@@ -3893,27 +3819,22 @@
                   </a:txBody>
                   <a:tcPr/>
                 </a:tc>
-                <a:extLst>
-                  <a:ext uri="{0D108BD9-81ED-4DB2-BD59-A6C34878D82A}">
-                    <a16:rowId xmlns:a16="http://schemas.microsoft.com/office/drawing/2014/main" val="10005"/>
-                  </a:ext>
-                </a:extLst>
               </a:tr>
-              <a:tr h="457200">
+              <a:tr h="685800">
                 <a:tc>
                   <a:txBody>
                     <a:bodyPr/>
                     <a:lstStyle/>
                     <a:p>
                       <a:pPr>
-                        <a:defRPr sz="1100">
+                        <a:defRPr sz="1200">
                           <a:solidFill>
-                            <a:srgbClr val="334155"/>
+                            <a:srgbClr val="000000"/>
                           </a:solidFill>
                         </a:defRPr>
                       </a:pPr>
                       <a:r>
-                        <a:t>App.css</a:t>
+                        <a:t>view_logs.js</a:t>
                       </a:r>
                     </a:p>
                   </a:txBody>
@@ -3925,40 +3846,35 @@
                     <a:lstStyle/>
                     <a:p>
                       <a:pPr>
-                        <a:defRPr sz="1100">
+                        <a:defRPr sz="1200">
                           <a:solidFill>
-                            <a:srgbClr val="334155"/>
+                            <a:srgbClr val="000000"/>
                           </a:solidFill>
                         </a:defRPr>
                       </a:pPr>
                       <a:r>
-                        <a:t>Premium dark-mode styling and user interface layout.</a:t>
+                        <a:t>Custom tool to see the Cloud Brain (Validation Logs).</a:t>
                       </a:r>
                     </a:p>
                   </a:txBody>
                   <a:tcPr/>
                 </a:tc>
-                <a:extLst>
-                  <a:ext uri="{0D108BD9-81ED-4DB2-BD59-A6C34878D82A}">
-                    <a16:rowId xmlns:a16="http://schemas.microsoft.com/office/drawing/2014/main" val="10006"/>
-                  </a:ext>
-                </a:extLst>
               </a:tr>
-              <a:tr h="457200">
+              <a:tr h="685800">
                 <a:tc>
                   <a:txBody>
                     <a:bodyPr/>
                     <a:lstStyle/>
                     <a:p>
                       <a:pPr>
-                        <a:defRPr sz="1100">
+                        <a:defRPr sz="1200">
                           <a:solidFill>
-                            <a:srgbClr val="334155"/>
+                            <a:srgbClr val="000000"/>
                           </a:solidFill>
                         </a:defRPr>
                       </a:pPr>
                       <a:r>
-                        <a:t>main.jsx</a:t>
+                        <a:t>apply_cors.js</a:t>
                       </a:r>
                     </a:p>
                   </a:txBody>
@@ -3970,125 +3886,30 @@
                     <a:lstStyle/>
                     <a:p>
                       <a:pPr>
-                        <a:defRPr sz="1100">
+                        <a:defRPr sz="1200">
                           <a:solidFill>
-                            <a:srgbClr val="334155"/>
+                            <a:srgbClr val="000000"/>
                           </a:solidFill>
                         </a:defRPr>
                       </a:pPr>
                       <a:r>
-                        <a:t>The 'Ignition' file that starts the React engine.</a:t>
+                        <a:t>Utility to unlock S3 security for the browser.</a:t>
                       </a:r>
                     </a:p>
                   </a:txBody>
                   <a:tcPr/>
                 </a:tc>
-                <a:extLst>
-                  <a:ext uri="{0D108BD9-81ED-4DB2-BD59-A6C34878D82A}">
-                    <a16:rowId xmlns:a16="http://schemas.microsoft.com/office/drawing/2014/main" val="10007"/>
-                  </a:ext>
-                </a:extLst>
               </a:tr>
-              <a:tr h="457200">
+              <a:tr h="685800">
                 <a:tc>
                   <a:txBody>
                     <a:bodyPr/>
                     <a:lstStyle/>
                     <a:p>
                       <a:pPr>
-                        <a:defRPr sz="1100">
+                        <a:defRPr sz="1200">
                           <a:solidFill>
-                            <a:srgbClr val="334155"/>
-                          </a:solidFill>
-                        </a:defRPr>
-                      </a:pPr>
-                      <a:r>
-                        <a:t>upload.spec.js</a:t>
-                      </a:r>
-                    </a:p>
-                  </a:txBody>
-                  <a:tcPr/>
-                </a:tc>
-                <a:tc>
-                  <a:txBody>
-                    <a:bodyPr/>
-                    <a:lstStyle/>
-                    <a:p>
-                      <a:pPr>
-                        <a:defRPr sz="1100">
-                          <a:solidFill>
-                            <a:srgbClr val="334155"/>
-                          </a:solidFill>
-                        </a:defRPr>
-                      </a:pPr>
-                      <a:r>
-                        <a:t>The script for the Playwright Robot Auditor.</a:t>
-                      </a:r>
-                    </a:p>
-                  </a:txBody>
-                  <a:tcPr/>
-                </a:tc>
-                <a:extLst>
-                  <a:ext uri="{0D108BD9-81ED-4DB2-BD59-A6C34878D82A}">
-                    <a16:rowId xmlns:a16="http://schemas.microsoft.com/office/drawing/2014/main" val="10008"/>
-                  </a:ext>
-                </a:extLst>
-              </a:tr>
-              <a:tr h="457200">
-                <a:tc>
-                  <a:txBody>
-                    <a:bodyPr/>
-                    <a:lstStyle/>
-                    <a:p>
-                      <a:pPr>
-                        <a:defRPr sz="1100">
-                          <a:solidFill>
-                            <a:srgbClr val="334155"/>
-                          </a:solidFill>
-                        </a:defRPr>
-                      </a:pPr>
-                      <a:r>
-                        <a:t>playwright.config.js</a:t>
-                      </a:r>
-                    </a:p>
-                  </a:txBody>
-                  <a:tcPr/>
-                </a:tc>
-                <a:tc>
-                  <a:txBody>
-                    <a:bodyPr/>
-                    <a:lstStyle/>
-                    <a:p>
-                      <a:pPr>
-                        <a:defRPr sz="1100">
-                          <a:solidFill>
-                            <a:srgbClr val="334155"/>
-                          </a:solidFill>
-                        </a:defRPr>
-                      </a:pPr>
-                      <a:r>
-                        <a:t>Master settings for the Robot Auditor.</a:t>
-                      </a:r>
-                    </a:p>
-                  </a:txBody>
-                  <a:tcPr/>
-                </a:tc>
-                <a:extLst>
-                  <a:ext uri="{0D108BD9-81ED-4DB2-BD59-A6C34878D82A}">
-                    <a16:rowId xmlns:a16="http://schemas.microsoft.com/office/drawing/2014/main" val="10009"/>
-                  </a:ext>
-                </a:extLst>
-              </a:tr>
-              <a:tr h="457200">
-                <a:tc>
-                  <a:txBody>
-                    <a:bodyPr/>
-                    <a:lstStyle/>
-                    <a:p>
-                      <a:pPr>
-                        <a:defRPr sz="1100">
-                          <a:solidFill>
-                            <a:srgbClr val="334155"/>
+                            <a:srgbClr val="000000"/>
                           </a:solidFill>
                         </a:defRPr>
                       </a:pPr>
@@ -4105,9 +3926,9 @@
                     <a:lstStyle/>
                     <a:p>
                       <a:pPr>
-                        <a:defRPr sz="1100">
+                        <a:defRPr sz="1200">
                           <a:solidFill>
-                            <a:srgbClr val="334155"/>
+                            <a:srgbClr val="000000"/>
                           </a:solidFill>
                         </a:defRPr>
                       </a:pPr>
@@ -4118,11 +3939,6 @@
                   </a:txBody>
                   <a:tcPr/>
                 </a:tc>
-                <a:extLst>
-                  <a:ext uri="{0D108BD9-81ED-4DB2-BD59-A6C34878D82A}">
-                    <a16:rowId xmlns:a16="http://schemas.microsoft.com/office/drawing/2014/main" val="10010"/>
-                  </a:ext>
-                </a:extLst>
               </a:tr>
             </a:tbl>
           </a:graphicData>
@@ -4137,7 +3953,7 @@
 </file>
 
 <file path=ppt/slides/slide14.xml><?xml version="1.0" encoding="utf-8"?>
-<p:sld xmlns:a="http://schemas.openxmlformats.org/drawingml/2006/main" xmlns:r="http://schemas.openxmlformats.org/officeDocument/2006/relationships" xmlns:p="http://schemas.openxmlformats.org/presentationml/2006/main">
+<p:sld xmlns:a="http://schemas.openxmlformats.org/drawingml/2006/main" xmlns:p="http://schemas.openxmlformats.org/presentationml/2006/main" xmlns:r="http://schemas.openxmlformats.org/officeDocument/2006/relationships">
   <p:cSld>
     <p:bg>
       <p:bgPr>
@@ -4153,14 +3969,7 @@
         <p:cNvGrpSpPr/>
         <p:nvPr/>
       </p:nvGrpSpPr>
-      <p:grpSpPr>
-        <a:xfrm>
-          <a:off x="0" y="0"/>
-          <a:ext cx="0" cy="0"/>
-          <a:chOff x="0" y="0"/>
-          <a:chExt cx="0" cy="0"/>
-        </a:xfrm>
-      </p:grpSpPr>
+      <p:grpSpPr/>
       <p:sp>
         <p:nvSpPr>
           <p:cNvPr id="2" name="Title 1"/>
@@ -4179,7 +3988,7 @@
             <a:pPr>
               <a:defRPr b="1">
                 <a:solidFill>
-                  <a:srgbClr val="0284C7"/>
+                  <a:srgbClr val="003366"/>
                 </a:solidFill>
               </a:defRPr>
             </a:pPr>
@@ -4206,46 +4015,16 @@
           <a:p>
             <a:pPr>
               <a:spcAft>
-                <a:spcPts val="1000"/>
+                <a:spcPts val="1200"/>
               </a:spcAft>
-              <a:defRPr sz="2000">
-                <a:solidFill>
-                  <a:srgbClr val="334155"/>
+              <a:defRPr sz="2200">
+                <a:solidFill>
+                  <a:srgbClr val="000000"/>
                 </a:solidFill>
               </a:defRPr>
             </a:pPr>
             <a:r>
-              <a:t>• This project demonstrates a fully automated, self-validating cloud pipeline.</a:t>
-            </a:r>
-          </a:p>
-          <a:p>
-            <a:pPr>
-              <a:spcAft>
-                <a:spcPts val="1000"/>
-              </a:spcAft>
-              <a:defRPr sz="2000">
-                <a:solidFill>
-                  <a:srgbClr val="334155"/>
-                </a:solidFill>
-              </a:defRPr>
-            </a:pPr>
-            <a:r>
-              <a:t>• By simulating AWS via Docker and LocalStack, we created a risk-free environment for Event-Driven Architecture.</a:t>
-            </a:r>
-          </a:p>
-          <a:p>
-            <a:pPr>
-              <a:spcAft>
-                <a:spcPts val="1000"/>
-              </a:spcAft>
-              <a:defRPr sz="2000">
-                <a:solidFill>
-                  <a:srgbClr val="334155"/>
-                </a:solidFill>
-              </a:defRPr>
-            </a:pPr>
-            <a:r>
-              <a:t>• We successfully linked React to Lambda via S3, with Playwright providing 100% automated proof of quality.</a:t>
+              <a:t>"This project demonstrates a fully automated, self-validating cloud pipeline. By simulating AWS locally via Docker and LocalStack, we have created a risk-free environment to test Event-Driven Architecture. We have successfully linked a React dashboard to a Lambda function via S3, and we have established a robust manual validation workflow."</a:t>
             </a:r>
           </a:p>
         </p:txBody>
@@ -4259,7 +4038,7 @@
 </file>
 
 <file path=ppt/slides/slide2.xml><?xml version="1.0" encoding="utf-8"?>
-<p:sld xmlns:a="http://schemas.openxmlformats.org/drawingml/2006/main" xmlns:r="http://schemas.openxmlformats.org/officeDocument/2006/relationships" xmlns:p="http://schemas.openxmlformats.org/presentationml/2006/main">
+<p:sld xmlns:a="http://schemas.openxmlformats.org/drawingml/2006/main" xmlns:p="http://schemas.openxmlformats.org/presentationml/2006/main" xmlns:r="http://schemas.openxmlformats.org/officeDocument/2006/relationships">
   <p:cSld>
     <p:bg>
       <p:bgPr>
@@ -4275,14 +4054,7 @@
         <p:cNvGrpSpPr/>
         <p:nvPr/>
       </p:nvGrpSpPr>
-      <p:grpSpPr>
-        <a:xfrm>
-          <a:off x="0" y="0"/>
-          <a:ext cx="0" cy="0"/>
-          <a:chOff x="0" y="0"/>
-          <a:chExt cx="0" cy="0"/>
-        </a:xfrm>
-      </p:grpSpPr>
+      <p:grpSpPr/>
       <p:sp>
         <p:nvSpPr>
           <p:cNvPr id="2" name="Title 1"/>
@@ -4301,7 +4073,7 @@
             <a:pPr>
               <a:defRPr b="1">
                 <a:solidFill>
-                  <a:srgbClr val="0284C7"/>
+                  <a:srgbClr val="003366"/>
                 </a:solidFill>
               </a:defRPr>
             </a:pPr>
@@ -4327,9 +4099,12 @@
           <a:lstStyle/>
           <a:p>
             <a:pPr>
-              <a:defRPr sz="2000">
-                <a:solidFill>
-                  <a:srgbClr val="334155"/>
+              <a:spcAft>
+                <a:spcPts val="1200"/>
+              </a:spcAft>
+              <a:defRPr sz="2200">
+                <a:solidFill>
+                  <a:srgbClr val="000000"/>
                 </a:solidFill>
               </a:defRPr>
             </a:pPr>
@@ -4339,9 +4114,12 @@
           </a:p>
           <a:p>
             <a:pPr>
-              <a:defRPr sz="2000">
-                <a:solidFill>
-                  <a:srgbClr val="334155"/>
+              <a:spcAft>
+                <a:spcPts val="1200"/>
+              </a:spcAft>
+              <a:defRPr sz="2200">
+                <a:solidFill>
+                  <a:srgbClr val="000000"/>
                 </a:solidFill>
               </a:defRPr>
             </a:pPr>
@@ -4351,26 +4129,17 @@
           </a:p>
           <a:p>
             <a:pPr>
-              <a:defRPr sz="2000">
-                <a:solidFill>
-                  <a:srgbClr val="334155"/>
+              <a:spcAft>
+                <a:spcPts val="1200"/>
+              </a:spcAft>
+              <a:defRPr sz="2200">
+                <a:solidFill>
+                  <a:srgbClr val="000000"/>
                 </a:solidFill>
               </a:defRPr>
             </a:pPr>
             <a:r>
               <a:t>• Docker: An isolated, tiny computer inside your laptop. It carves out a slice of your CPU and memory separate from your personal files.</a:t>
-            </a:r>
-          </a:p>
-          <a:p>
-            <a:pPr>
-              <a:defRPr sz="2000">
-                <a:solidFill>
-                  <a:srgbClr val="334155"/>
-                </a:solidFill>
-              </a:defRPr>
-            </a:pPr>
-            <a:r>
-              <a:t>• LocalStack: A simulator inside the Magic Box that 'pretends' to be the AWS cloud. It acts and talks like the real AWS locally.</a:t>
             </a:r>
           </a:p>
         </p:txBody>
@@ -4384,7 +4153,7 @@
 </file>
 
 <file path=ppt/slides/slide3.xml><?xml version="1.0" encoding="utf-8"?>
-<p:sld xmlns:a="http://schemas.openxmlformats.org/drawingml/2006/main" xmlns:r="http://schemas.openxmlformats.org/officeDocument/2006/relationships" xmlns:p="http://schemas.openxmlformats.org/presentationml/2006/main">
+<p:sld xmlns:a="http://schemas.openxmlformats.org/drawingml/2006/main" xmlns:p="http://schemas.openxmlformats.org/presentationml/2006/main" xmlns:r="http://schemas.openxmlformats.org/officeDocument/2006/relationships">
   <p:cSld>
     <p:bg>
       <p:bgPr>
@@ -4400,14 +4169,7 @@
         <p:cNvGrpSpPr/>
         <p:nvPr/>
       </p:nvGrpSpPr>
-      <p:grpSpPr>
-        <a:xfrm>
-          <a:off x="0" y="0"/>
-          <a:ext cx="0" cy="0"/>
-          <a:chOff x="0" y="0"/>
-          <a:chExt cx="0" cy="0"/>
-        </a:xfrm>
-      </p:grpSpPr>
+      <p:grpSpPr/>
       <p:sp>
         <p:nvSpPr>
           <p:cNvPr id="2" name="Title 1"/>
@@ -4426,7 +4188,7 @@
             <a:pPr>
               <a:defRPr b="1">
                 <a:solidFill>
-                  <a:srgbClr val="0284C7"/>
+                  <a:srgbClr val="003366"/>
                 </a:solidFill>
               </a:defRPr>
             </a:pPr>
@@ -4452,26 +4214,32 @@
           <a:lstStyle/>
           <a:p>
             <a:pPr>
-              <a:defRPr sz="2000">
-                <a:solidFill>
-                  <a:srgbClr val="334155"/>
+              <a:spcAft>
+                <a:spcPts val="1200"/>
+              </a:spcAft>
+              <a:defRPr sz="2200">
+                <a:solidFill>
+                  <a:srgbClr val="000000"/>
                 </a:solidFill>
               </a:defRPr>
             </a:pPr>
             <a:r>
-              <a:t>• The Tunnel (Port 4566): We created a digital tunnel that connects your computer to the simulator inside the box.</a:t>
+              <a:t>• LocalStack: A simulator inside the Docker 'Magic Box' that 'pretends' to be the AWS cloud. It looks, acts, and talks exactly like the real AWS.</a:t>
             </a:r>
           </a:p>
           <a:p>
             <a:pPr>
-              <a:defRPr sz="2000">
-                <a:solidFill>
-                  <a:srgbClr val="334155"/>
+              <a:spcAft>
+                <a:spcPts val="1200"/>
+              </a:spcAft>
+              <a:defRPr sz="2200">
+                <a:solidFill>
+                  <a:srgbClr val="000000"/>
                 </a:solidFill>
               </a:defRPr>
             </a:pPr>
             <a:r>
-              <a:t>• Every piece of code we wrote sends its data through this specific tunnel to ensure the simulation stays isolated and fast.</a:t>
+              <a:t>• The Tunnel (Port 4566): We created a digital tunnel (Port 4566) that connects your computer to the simulator inside the box. Every piece of code we wrote sends its data through this tunnel.</a:t>
             </a:r>
           </a:p>
         </p:txBody>
@@ -4485,7 +4253,7 @@
 </file>
 
 <file path=ppt/slides/slide4.xml><?xml version="1.0" encoding="utf-8"?>
-<p:sld xmlns:a="http://schemas.openxmlformats.org/drawingml/2006/main" xmlns:r="http://schemas.openxmlformats.org/officeDocument/2006/relationships" xmlns:p="http://schemas.openxmlformats.org/presentationml/2006/main">
+<p:sld xmlns:a="http://schemas.openxmlformats.org/drawingml/2006/main" xmlns:p="http://schemas.openxmlformats.org/presentationml/2006/main" xmlns:r="http://schemas.openxmlformats.org/officeDocument/2006/relationships">
   <p:cSld>
     <p:bg>
       <p:bgPr>
@@ -4501,14 +4269,7 @@
         <p:cNvGrpSpPr/>
         <p:nvPr/>
       </p:nvGrpSpPr>
-      <p:grpSpPr>
-        <a:xfrm>
-          <a:off x="0" y="0"/>
-          <a:ext cx="0" cy="0"/>
-          <a:chOff x="0" y="0"/>
-          <a:chExt cx="0" cy="0"/>
-        </a:xfrm>
-      </p:grpSpPr>
+      <p:grpSpPr/>
       <p:sp>
         <p:nvSpPr>
           <p:cNvPr id="2" name="Title 1"/>
@@ -4527,7 +4288,7 @@
             <a:pPr>
               <a:defRPr b="1">
                 <a:solidFill>
-                  <a:srgbClr val="0284C7"/>
+                  <a:srgbClr val="003366"/>
                 </a:solidFill>
               </a:defRPr>
             </a:pPr>
@@ -4553,9 +4314,12 @@
           <a:lstStyle/>
           <a:p>
             <a:pPr>
-              <a:defRPr sz="2000">
-                <a:solidFill>
-                  <a:srgbClr val="334155"/>
+              <a:spcAft>
+                <a:spcPts val="1200"/>
+              </a:spcAft>
+              <a:defRPr sz="2200">
+                <a:solidFill>
+                  <a:srgbClr val="000000"/>
                 </a:solidFill>
               </a:defRPr>
             </a:pPr>
@@ -4565,26 +4329,32 @@
           </a:p>
           <a:p>
             <a:pPr>
-              <a:defRPr sz="2000">
-                <a:solidFill>
-                  <a:srgbClr val="334155"/>
+              <a:spcAft>
+                <a:spcPts val="1200"/>
+              </a:spcAft>
+              <a:defRPr sz="2200">
+                <a:solidFill>
+                  <a:srgbClr val="000000"/>
                 </a:solidFill>
               </a:defRPr>
             </a:pPr>
             <a:r>
-              <a:t>• S3 (Simple Storage Service): A giant, programmable hard drive. We created a 'Bucket' called university-docs to store uploaded files.</a:t>
+              <a:t>• S3 (Simple Storage Service): A giant, programmable hard drive. We created a 'Bucket' (a folder) called university-docs to store the files you upload.</a:t>
             </a:r>
           </a:p>
           <a:p>
             <a:pPr>
-              <a:defRPr sz="2000">
-                <a:solidFill>
-                  <a:srgbClr val="334155"/>
+              <a:spcAft>
+                <a:spcPts val="1200"/>
+              </a:spcAft>
+              <a:defRPr sz="2200">
+                <a:solidFill>
+                  <a:srgbClr val="000000"/>
                 </a:solidFill>
               </a:defRPr>
             </a:pPr>
             <a:r>
-              <a:t>• Lambda (The Worker): Serverless computing. A worker who stays asleep until an alarm goes off. It wakes up, validates, and goes back to sleep.</a:t>
+              <a:t>• Lambda (The Worker): This is 'Serverless' computing. A worker who stays asleep until an alarm goes off. When a file is uploaded, the worker wakes up, validates, and goes back to sleep.</a:t>
             </a:r>
           </a:p>
         </p:txBody>
@@ -4598,7 +4368,7 @@
 </file>
 
 <file path=ppt/slides/slide5.xml><?xml version="1.0" encoding="utf-8"?>
-<p:sld xmlns:a="http://schemas.openxmlformats.org/drawingml/2006/main" xmlns:r="http://schemas.openxmlformats.org/officeDocument/2006/relationships" xmlns:p="http://schemas.openxmlformats.org/presentationml/2006/main">
+<p:sld xmlns:a="http://schemas.openxmlformats.org/drawingml/2006/main" xmlns:p="http://schemas.openxmlformats.org/presentationml/2006/main" xmlns:r="http://schemas.openxmlformats.org/officeDocument/2006/relationships">
   <p:cSld>
     <p:bg>
       <p:bgPr>
@@ -4614,14 +4384,7 @@
         <p:cNvGrpSpPr/>
         <p:nvPr/>
       </p:nvGrpSpPr>
-      <p:grpSpPr>
-        <a:xfrm>
-          <a:off x="0" y="0"/>
-          <a:ext cx="0" cy="0"/>
-          <a:chOff x="0" y="0"/>
-          <a:chExt cx="0" cy="0"/>
-        </a:xfrm>
-      </p:grpSpPr>
+      <p:grpSpPr/>
       <p:sp>
         <p:nvSpPr>
           <p:cNvPr id="2" name="Title 1"/>
@@ -4640,7 +4403,7 @@
             <a:pPr>
               <a:defRPr b="1">
                 <a:solidFill>
-                  <a:srgbClr val="0284C7"/>
+                  <a:srgbClr val="003366"/>
                 </a:solidFill>
               </a:defRPr>
             </a:pPr>
@@ -4666,38 +4429,32 @@
           <a:lstStyle/>
           <a:p>
             <a:pPr>
-              <a:defRPr sz="2000">
-                <a:solidFill>
-                  <a:srgbClr val="334155"/>
+              <a:spcAft>
+                <a:spcPts val="1200"/>
+              </a:spcAft>
+              <a:defRPr sz="2200">
+                <a:solidFill>
+                  <a:srgbClr val="000000"/>
                 </a:solidFill>
               </a:defRPr>
             </a:pPr>
             <a:r>
-              <a:t>• CloudWatch (The Logbook): A digital notebook.</a:t>
+              <a:t>• CloudWatch (The Logbook): This is a digital notebook.</a:t>
             </a:r>
           </a:p>
           <a:p>
             <a:pPr>
-              <a:defRPr sz="2000">
-                <a:solidFill>
-                  <a:srgbClr val="334155"/>
+              <a:spcAft>
+                <a:spcPts val="1200"/>
+              </a:spcAft>
+              <a:defRPr sz="2200">
+                <a:solidFill>
+                  <a:srgbClr val="000000"/>
                 </a:solidFill>
               </a:defRPr>
             </a:pPr>
             <a:r>
               <a:t>• Every time the Worker (Lambda) wakes up, they write a note here so we can verify their work later.</a:t>
-            </a:r>
-          </a:p>
-          <a:p>
-            <a:pPr>
-              <a:defRPr sz="2000">
-                <a:solidFill>
-                  <a:srgbClr val="334155"/>
-                </a:solidFill>
-              </a:defRPr>
-            </a:pPr>
-            <a:r>
-              <a:t>• This provides the 'Audit Trail' necessary for software validation.</a:t>
             </a:r>
           </a:p>
         </p:txBody>
@@ -4711,7 +4468,7 @@
 </file>
 
 <file path=ppt/slides/slide6.xml><?xml version="1.0" encoding="utf-8"?>
-<p:sld xmlns:a="http://schemas.openxmlformats.org/drawingml/2006/main" xmlns:r="http://schemas.openxmlformats.org/officeDocument/2006/relationships" xmlns:p="http://schemas.openxmlformats.org/presentationml/2006/main">
+<p:sld xmlns:a="http://schemas.openxmlformats.org/drawingml/2006/main" xmlns:p="http://schemas.openxmlformats.org/presentationml/2006/main" xmlns:r="http://schemas.openxmlformats.org/officeDocument/2006/relationships">
   <p:cSld>
     <p:bg>
       <p:bgPr>
@@ -4727,14 +4484,7 @@
         <p:cNvGrpSpPr/>
         <p:nvPr/>
       </p:nvGrpSpPr>
-      <p:grpSpPr>
-        <a:xfrm>
-          <a:off x="0" y="0"/>
-          <a:ext cx="0" cy="0"/>
-          <a:chOff x="0" y="0"/>
-          <a:chExt cx="0" cy="0"/>
-        </a:xfrm>
-      </p:grpSpPr>
+      <p:grpSpPr/>
       <p:sp>
         <p:nvSpPr>
           <p:cNvPr id="2" name="Title 1"/>
@@ -4753,7 +4503,7 @@
             <a:pPr>
               <a:defRPr b="1">
                 <a:solidFill>
-                  <a:srgbClr val="0284C7"/>
+                  <a:srgbClr val="003366"/>
                 </a:solidFill>
               </a:defRPr>
             </a:pPr>
@@ -4779,26 +4529,32 @@
           <a:lstStyle/>
           <a:p>
             <a:pPr>
-              <a:defRPr sz="2000">
-                <a:solidFill>
-                  <a:srgbClr val="334155"/>
+              <a:spcAft>
+                <a:spcPts val="1200"/>
+              </a:spcAft>
+              <a:defRPr sz="2200">
+                <a:solidFill>
+                  <a:srgbClr val="000000"/>
                 </a:solidFill>
               </a:defRPr>
             </a:pPr>
             <a:r>
-              <a:t>1. The Courier (AWS SDK): Our React website uses the AWS SDK library. Think of this as a highly trained Courier with the address: http://localhost:4566.</a:t>
+              <a:t>1. The Courier (AWS SDK): Our React website uses a special library called the AWS SDK. Think of this as a highly trained Courier. We gave the Courier a specific address: http://localhost:4566.</a:t>
             </a:r>
           </a:p>
           <a:p>
             <a:pPr>
-              <a:defRPr sz="2000">
-                <a:solidFill>
-                  <a:srgbClr val="334155"/>
+              <a:spcAft>
+                <a:spcPts val="1200"/>
+              </a:spcAft>
+              <a:defRPr sz="2200">
+                <a:solidFill>
+                  <a:srgbClr val="000000"/>
                 </a:solidFill>
               </a:defRPr>
             </a:pPr>
             <a:r>
-              <a:t>2. The Handshake: When you click 'Upload,' the website hands the file to the Courier. The Courier packages it for the cloud and runs it through the Tunnel.</a:t>
+              <a:t>2. The Handshake: When you click 'Upload,' the website hands the file to the Courier. The Courier packages it into a specific format that cloud systems understand.</a:t>
             </a:r>
           </a:p>
         </p:txBody>
@@ -4812,7 +4568,7 @@
 </file>
 
 <file path=ppt/slides/slide7.xml><?xml version="1.0" encoding="utf-8"?>
-<p:sld xmlns:a="http://schemas.openxmlformats.org/drawingml/2006/main" xmlns:r="http://schemas.openxmlformats.org/officeDocument/2006/relationships" xmlns:p="http://schemas.openxmlformats.org/presentationml/2006/main">
+<p:sld xmlns:a="http://schemas.openxmlformats.org/drawingml/2006/main" xmlns:p="http://schemas.openxmlformats.org/presentationml/2006/main" xmlns:r="http://schemas.openxmlformats.org/officeDocument/2006/relationships">
   <p:cSld>
     <p:bg>
       <p:bgPr>
@@ -4828,14 +4584,7 @@
         <p:cNvGrpSpPr/>
         <p:nvPr/>
       </p:nvGrpSpPr>
-      <p:grpSpPr>
-        <a:xfrm>
-          <a:off x="0" y="0"/>
-          <a:ext cx="0" cy="0"/>
-          <a:chOff x="0" y="0"/>
-          <a:chExt cx="0" cy="0"/>
-        </a:xfrm>
-      </p:grpSpPr>
+      <p:grpSpPr/>
       <p:sp>
         <p:nvSpPr>
           <p:cNvPr id="2" name="Title 1"/>
@@ -4854,7 +4603,7 @@
             <a:pPr>
               <a:defRPr b="1">
                 <a:solidFill>
-                  <a:srgbClr val="0284C7"/>
+                  <a:srgbClr val="003366"/>
                 </a:solidFill>
               </a:defRPr>
             </a:pPr>
@@ -4880,9 +4629,12 @@
           <a:lstStyle/>
           <a:p>
             <a:pPr>
-              <a:defRPr sz="2000">
-                <a:solidFill>
-                  <a:srgbClr val="334155"/>
+              <a:spcAft>
+                <a:spcPts val="1200"/>
+              </a:spcAft>
+              <a:defRPr sz="2200">
+                <a:solidFill>
+                  <a:srgbClr val="000000"/>
                 </a:solidFill>
               </a:defRPr>
             </a:pPr>
@@ -4892,26 +4644,17 @@
           </a:p>
           <a:p>
             <a:pPr>
-              <a:defRPr sz="2000">
-                <a:solidFill>
-                  <a:srgbClr val="334155"/>
+              <a:spcAft>
+                <a:spcPts val="1200"/>
+              </a:spcAft>
+              <a:defRPr sz="2200">
+                <a:solidFill>
+                  <a:srgbClr val="000000"/>
                 </a:solidFill>
               </a:defRPr>
             </a:pPr>
             <a:r>
               <a:t>• It catches the file, identifies it as an 'S3 Storage' request, and places it in the storage room.</a:t>
-            </a:r>
-          </a:p>
-          <a:p>
-            <a:pPr>
-              <a:defRPr sz="2000">
-                <a:solidFill>
-                  <a:srgbClr val="334155"/>
-                </a:solidFill>
-              </a:defRPr>
-            </a:pPr>
-            <a:r>
-              <a:t>• This completes the 'External to Internal' data transfer.</a:t>
             </a:r>
           </a:p>
         </p:txBody>
@@ -4925,7 +4668,7 @@
 </file>
 
 <file path=ppt/slides/slide8.xml><?xml version="1.0" encoding="utf-8"?>
-<p:sld xmlns:a="http://schemas.openxmlformats.org/drawingml/2006/main" xmlns:r="http://schemas.openxmlformats.org/officeDocument/2006/relationships" xmlns:p="http://schemas.openxmlformats.org/presentationml/2006/main">
+<p:sld xmlns:a="http://schemas.openxmlformats.org/drawingml/2006/main" xmlns:p="http://schemas.openxmlformats.org/presentationml/2006/main" xmlns:r="http://schemas.openxmlformats.org/officeDocument/2006/relationships">
   <p:cSld>
     <p:bg>
       <p:bgPr>
@@ -4941,14 +4684,7 @@
         <p:cNvGrpSpPr/>
         <p:nvPr/>
       </p:nvGrpSpPr>
-      <p:grpSpPr>
-        <a:xfrm>
-          <a:off x="0" y="0"/>
-          <a:ext cx="0" cy="0"/>
-          <a:chOff x="0" y="0"/>
-          <a:chExt cx="0" cy="0"/>
-        </a:xfrm>
-      </p:grpSpPr>
+      <p:grpSpPr/>
       <p:sp>
         <p:nvSpPr>
           <p:cNvPr id="2" name="Title 1"/>
@@ -4967,7 +4703,7 @@
             <a:pPr>
               <a:defRPr b="1">
                 <a:solidFill>
-                  <a:srgbClr val="0284C7"/>
+                  <a:srgbClr val="003366"/>
                 </a:solidFill>
               </a:defRPr>
             </a:pPr>
@@ -4993,9 +4729,12 @@
           <a:lstStyle/>
           <a:p>
             <a:pPr>
-              <a:defRPr sz="2000">
-                <a:solidFill>
-                  <a:srgbClr val="334155"/>
+              <a:spcAft>
+                <a:spcPts val="1200"/>
+              </a:spcAft>
+              <a:defRPr sz="2200">
+                <a:solidFill>
+                  <a:srgbClr val="000000"/>
                 </a:solidFill>
               </a:defRPr>
             </a:pPr>
@@ -5005,21 +4744,27 @@
           </a:p>
           <a:p>
             <a:pPr>
-              <a:defRPr sz="2000">
-                <a:solidFill>
-                  <a:srgbClr val="334155"/>
+              <a:spcAft>
+                <a:spcPts val="1200"/>
+              </a:spcAft>
+              <a:defRPr sz="2200">
+                <a:solidFill>
+                  <a:srgbClr val="000000"/>
                 </a:solidFill>
               </a:defRPr>
             </a:pPr>
             <a:r>
-              <a:t>• The Setup: We wrote a blueprint (serverless.yml) that installed a sensor in the S3 storage room.</a:t>
+              <a:t>• The Setup: We wrote a blueprint (the serverless.yml file) that installed a sensor in the S3 storage room.</a:t>
             </a:r>
           </a:p>
           <a:p>
             <a:pPr>
-              <a:defRPr sz="2000">
-                <a:solidFill>
-                  <a:srgbClr val="334155"/>
+              <a:spcAft>
+                <a:spcPts val="1200"/>
+              </a:spcAft>
+              <a:defRPr sz="2200">
+                <a:solidFill>
+                  <a:srgbClr val="000000"/>
                 </a:solidFill>
               </a:defRPr>
             </a:pPr>
@@ -5038,7 +4783,7 @@
 </file>
 
 <file path=ppt/slides/slide9.xml><?xml version="1.0" encoding="utf-8"?>
-<p:sld xmlns:a="http://schemas.openxmlformats.org/drawingml/2006/main" xmlns:r="http://schemas.openxmlformats.org/officeDocument/2006/relationships" xmlns:p="http://schemas.openxmlformats.org/presentationml/2006/main">
+<p:sld xmlns:a="http://schemas.openxmlformats.org/drawingml/2006/main" xmlns:p="http://schemas.openxmlformats.org/presentationml/2006/main" xmlns:r="http://schemas.openxmlformats.org/officeDocument/2006/relationships">
   <p:cSld>
     <p:bg>
       <p:bgPr>
@@ -5054,14 +4799,7 @@
         <p:cNvGrpSpPr/>
         <p:nvPr/>
       </p:nvGrpSpPr>
-      <p:grpSpPr>
-        <a:xfrm>
-          <a:off x="0" y="0"/>
-          <a:ext cx="0" cy="0"/>
-          <a:chOff x="0" y="0"/>
-          <a:chExt cx="0" cy="0"/>
-        </a:xfrm>
-      </p:grpSpPr>
+      <p:grpSpPr/>
       <p:sp>
         <p:nvSpPr>
           <p:cNvPr id="2" name="Title 1"/>
@@ -5080,7 +4818,7 @@
             <a:pPr>
               <a:defRPr b="1">
                 <a:solidFill>
-                  <a:srgbClr val="0284C7"/>
+                  <a:srgbClr val="003366"/>
                 </a:solidFill>
               </a:defRPr>
             </a:pPr>
@@ -5106,9 +4844,12 @@
           <a:lstStyle/>
           <a:p>
             <a:pPr>
-              <a:defRPr sz="2000">
-                <a:solidFill>
-                  <a:srgbClr val="334155"/>
+              <a:spcAft>
+                <a:spcPts val="1200"/>
+              </a:spcAft>
+              <a:defRPr sz="2200">
+                <a:solidFill>
+                  <a:srgbClr val="000000"/>
                 </a:solidFill>
               </a:defRPr>
             </a:pPr>
@@ -5118,21 +4859,27 @@
           </a:p>
           <a:p>
             <a:pPr>
-              <a:defRPr sz="2000">
-                <a:solidFill>
-                  <a:srgbClr val="334155"/>
+              <a:spcAft>
+                <a:spcPts val="1200"/>
+              </a:spcAft>
+              <a:defRPr sz="2200">
+                <a:solidFill>
+                  <a:srgbClr val="000000"/>
                 </a:solidFill>
               </a:defRPr>
             </a:pPr>
             <a:r>
-              <a:t>• The worker receives a 'Note' (JSON Event Object) telling it the file's name and size.</a:t>
+              <a:t>• The worker receives a 'Note' (a JSON Event Object) telling it the file's name and size.</a:t>
             </a:r>
           </a:p>
           <a:p>
             <a:pPr>
-              <a:defRPr sz="2000">
-                <a:solidFill>
-                  <a:srgbClr val="334155"/>
+              <a:spcAft>
+                <a:spcPts val="1200"/>
+              </a:spcAft>
+              <a:defRPr sz="2200">
+                <a:solidFill>
+                  <a:srgbClr val="000000"/>
                 </a:solidFill>
               </a:defRPr>
             </a:pPr>

</xml_diff>